<commit_message>
Correct Fall 2026 Lab 1 instructions and course files
</commit_message>
<xml_diff>
--- a/site/docs/MIE402_Lecture02_Sampling_Jupyter_PreLab1_Fall2026.pptx
+++ b/site/docs/MIE402_Lecture02_Sampling_Jupyter_PreLab1_Fall2026.pptx
@@ -493,7 +493,7 @@
           </a:p>
           <a:p xmlns:a="http://schemas.openxmlformats.org/drawingml/2006/main">
             <a:r>
-              <a:t>SOURCE: 2_Fundamentals.pdf; 3_Lab1_Theory.pdf; 4_Lab1_Exp.pdf. Source decks by Prof. T. Leo Liu, Spring 2026; rewritten for Fall 2026. Native charts are calculated teaching examples, not measured laboratory data.</a:t>
+              <a:t>SOURCE: 2_Fundamentals.pdf; 3_Lab1_Theory.pdf; 4_Lab1_Exp.pdf. Adapted from supplied prior-course source materials and rewritten for Fall 2026. Native charts are calculated teaching examples, not measured laboratory data.</a:t>
             </a:r>
           </a:p>
         </p:txBody>
@@ -583,7 +583,7 @@
           </a:p>
           <a:p xmlns:a="http://schemas.openxmlformats.org/drawingml/2006/main">
             <a:r>
-              <a:t>SOURCE: 3_Lab1_Theory.pdf p. 5; 4_Lab1_Exp.pdf p. 8. Source decks by Prof. T. Leo Liu, Spring 2026; rewritten for Fall 2026. Native charts are calculated teaching examples, not measured laboratory data.</a:t>
+              <a:t>SOURCE: 3_Lab1_Theory.pdf p. 5; 4_Lab1_Exp.pdf p. 8. Adapted from supplied prior-course source materials and rewritten for Fall 2026. Native charts are calculated teaching examples, not measured laboratory data.</a:t>
             </a:r>
           </a:p>
         </p:txBody>
@@ -673,7 +673,7 @@
           </a:p>
           <a:p xmlns:a="http://schemas.openxmlformats.org/drawingml/2006/main">
             <a:r>
-              <a:t>SOURCE: Earlier Lecture 02 teaching example; 4_Lab1_Exp.pdf pp. 7–8. Source decks by Prof. T. Leo Liu, Spring 2026; rewritten for Fall 2026. Native charts are calculated teaching examples, not measured laboratory data.</a:t>
+              <a:t>SOURCE: Earlier Lecture 02 teaching example; 4_Lab1_Exp.pdf pp. 7–8. Adapted from supplied prior-course source materials and rewritten for Fall 2026. Native charts are calculated teaching examples, not measured laboratory data.</a:t>
             </a:r>
           </a:p>
         </p:txBody>
@@ -763,7 +763,7 @@
           </a:p>
           <a:p xmlns:a="http://schemas.openxmlformats.org/drawingml/2006/main">
             <a:r>
-              <a:t>SOURCE: Earlier Lecture 02 teaching example; 4_Lab1_Exp.pdf pp. 7–8. Source decks by Prof. T. Leo Liu, Spring 2026; rewritten for Fall 2026. Native charts are calculated teaching examples, not measured laboratory data.</a:t>
+              <a:t>SOURCE: Earlier Lecture 02 teaching example; 4_Lab1_Exp.pdf pp. 7–8. Adapted from supplied prior-course source materials and rewritten for Fall 2026. Native charts are calculated teaching examples, not measured laboratory data.</a:t>
             </a:r>
           </a:p>
         </p:txBody>
@@ -853,7 +853,7 @@
           </a:p>
           <a:p xmlns:a="http://schemas.openxmlformats.org/drawingml/2006/main">
             <a:r>
-              <a:t>SOURCE: Earlier Lecture 02 teaching example; 4_Lab1_Exp.pdf pp. 7–8. Source decks by Prof. T. Leo Liu, Spring 2026; rewritten for Fall 2026. Native charts are calculated teaching examples, not measured laboratory data.</a:t>
+              <a:t>SOURCE: Earlier Lecture 02 teaching example; 4_Lab1_Exp.pdf pp. 7–8. Adapted from supplied prior-course source materials and rewritten for Fall 2026. Native charts are calculated teaching examples, not measured laboratory data.</a:t>
             </a:r>
           </a:p>
         </p:txBody>
@@ -943,7 +943,7 @@
           </a:p>
           <a:p xmlns:a="http://schemas.openxmlformats.org/drawingml/2006/main">
             <a:r>
-              <a:t>SOURCE: Earlier Lecture 02 teaching example; 4_Lab1_Exp.pdf pp. 7–8. Source decks by Prof. T. Leo Liu, Spring 2026; rewritten for Fall 2026. Native charts are calculated teaching examples, not measured laboratory data.</a:t>
+              <a:t>SOURCE: Earlier Lecture 02 teaching example; 4_Lab1_Exp.pdf pp. 7–8. Adapted from supplied prior-course source materials and rewritten for Fall 2026. Native charts are calculated teaching examples, not measured laboratory data.</a:t>
             </a:r>
           </a:p>
         </p:txBody>
@@ -1033,7 +1033,7 @@
           </a:p>
           <a:p xmlns:a="http://schemas.openxmlformats.org/drawingml/2006/main">
             <a:r>
-              <a:t>SOURCE: 4_Lab1_Exp.pdf p. 8. Source decks by Prof. T. Leo Liu, Spring 2026; rewritten for Fall 2026. Native charts are calculated teaching examples, not measured laboratory data.</a:t>
+              <a:t>SOURCE: 4_Lab1_Exp.pdf p. 8. Adapted from supplied prior-course source materials and rewritten for Fall 2026. Native charts are calculated teaching examples, not measured laboratory data.</a:t>
             </a:r>
           </a:p>
         </p:txBody>
@@ -1123,7 +1123,7 @@
           </a:p>
           <a:p xmlns:a="http://schemas.openxmlformats.org/drawingml/2006/main">
             <a:r>
-              <a:t>SOURCE: 4_Lab1_Exp.pdf p. 7; 3_Lab1_Theory.pdf p. 4. Source decks by Prof. T. Leo Liu, Spring 2026; rewritten for Fall 2026. Native charts are calculated teaching examples, not measured laboratory data.</a:t>
+              <a:t>SOURCE: 4_Lab1_Exp.pdf p. 7; 3_Lab1_Theory.pdf p. 4. Adapted from supplied prior-course source materials and rewritten for Fall 2026. Native charts are calculated teaching examples, not measured laboratory data.</a:t>
             </a:r>
           </a:p>
         </p:txBody>
@@ -1213,7 +1213,7 @@
           </a:p>
           <a:p xmlns:a="http://schemas.openxmlformats.org/drawingml/2006/main">
             <a:r>
-              <a:t>SOURCE: Earlier Lecture 02 teaching example; 4_Lab1_Exp.pdf pp. 7–8. Source decks by Prof. T. Leo Liu, Spring 2026; rewritten for Fall 2026. Native charts are calculated teaching examples, not measured laboratory data.</a:t>
+              <a:t>SOURCE: Earlier Lecture 02 teaching example; 4_Lab1_Exp.pdf pp. 7–8. Adapted from supplied prior-course source materials and rewritten for Fall 2026. Native charts are calculated teaching examples, not measured laboratory data.</a:t>
             </a:r>
           </a:p>
         </p:txBody>
@@ -1303,7 +1303,7 @@
           </a:p>
           <a:p xmlns:a="http://schemas.openxmlformats.org/drawingml/2006/main">
             <a:r>
-              <a:t>SOURCE: Earlier Lecture 02 teaching example; 4_Lab1_Exp.pdf pp. 7–8. Source decks by Prof. T. Leo Liu, Spring 2026; rewritten for Fall 2026. Native charts are calculated teaching examples, not measured laboratory data.</a:t>
+              <a:t>SOURCE: Earlier Lecture 02 teaching example; 4_Lab1_Exp.pdf pp. 7–8. Adapted from supplied prior-course source materials and rewritten for Fall 2026. Native charts are calculated teaching examples, not measured laboratory data.</a:t>
             </a:r>
           </a:p>
         </p:txBody>
@@ -1393,7 +1393,7 @@
           </a:p>
           <a:p xmlns:a="http://schemas.openxmlformats.org/drawingml/2006/main">
             <a:r>
-              <a:t>SOURCE: Earlier Lecture 02 teaching example; 4_Lab1_Exp.pdf pp. 7–8. Source decks by Prof. T. Leo Liu, Spring 2026; rewritten for Fall 2026. Native charts are calculated teaching examples, not measured laboratory data.</a:t>
+              <a:t>SOURCE: Earlier Lecture 02 teaching example; 4_Lab1_Exp.pdf pp. 7–8. Adapted from supplied prior-course source materials and rewritten for Fall 2026. Native charts are calculated teaching examples, not measured laboratory data.</a:t>
             </a:r>
           </a:p>
         </p:txBody>
@@ -1483,7 +1483,7 @@
           </a:p>
           <a:p xmlns:a="http://schemas.openxmlformats.org/drawingml/2006/main">
             <a:r>
-              <a:t>SOURCE: 2_Fundamentals.pdf p. 7; 3_Lab1_Theory.pdf p. 6. Source decks by Prof. T. Leo Liu, Spring 2026; rewritten for Fall 2026. Native charts are calculated teaching examples, not measured laboratory data.</a:t>
+              <a:t>SOURCE: 2_Fundamentals.pdf p. 7; 3_Lab1_Theory.pdf p. 6. Adapted from supplied prior-course source materials and rewritten for Fall 2026. Native charts are calculated teaching examples, not measured laboratory data.</a:t>
             </a:r>
           </a:p>
         </p:txBody>
@@ -1573,7 +1573,7 @@
           </a:p>
           <a:p xmlns:a="http://schemas.openxmlformats.org/drawingml/2006/main">
             <a:r>
-              <a:t>SOURCE: Earlier Lecture 02 teaching example; 4_Lab1_Exp.pdf pp. 7–8. Source decks by Prof. T. Leo Liu, Spring 2026; rewritten for Fall 2026. Native charts are calculated teaching examples, not measured laboratory data.</a:t>
+              <a:t>SOURCE: Earlier Lecture 02 teaching example; 4_Lab1_Exp.pdf pp. 7–8. Adapted from supplied prior-course source materials and rewritten for Fall 2026. Native charts are calculated teaching examples, not measured laboratory data.</a:t>
             </a:r>
           </a:p>
         </p:txBody>
@@ -1663,7 +1663,7 @@
           </a:p>
           <a:p xmlns:a="http://schemas.openxmlformats.org/drawingml/2006/main">
             <a:r>
-              <a:t>SOURCE: 4_Lab1_Exp.pdf p. 8. Source decks by Prof. T. Leo Liu, Spring 2026; rewritten for Fall 2026. Native charts are calculated teaching examples, not measured laboratory data.</a:t>
+              <a:t>SOURCE: 4_Lab1_Exp.pdf p. 8. Adapted from supplied prior-course source materials and rewritten for Fall 2026. Native charts are calculated teaching examples, not measured laboratory data.</a:t>
             </a:r>
           </a:p>
         </p:txBody>
@@ -1753,7 +1753,7 @@
           </a:p>
           <a:p xmlns:a="http://schemas.openxmlformats.org/drawingml/2006/main">
             <a:r>
-              <a:t>SOURCE: 4_Lab1_Exp.pdf p. 10; LAB1_MIE402.pdf p. 2. Source decks by Prof. T. Leo Liu, Spring 2026; rewritten for Fall 2026. Native charts are calculated teaching examples, not measured laboratory data.</a:t>
+              <a:t>SOURCE: 4_Lab1_Exp.pdf p. 10; LAB1_MIE402.pdf p. 2. Adapted from supplied prior-course source materials and rewritten for Fall 2026. Native charts are calculated teaching examples, not measured laboratory data.</a:t>
             </a:r>
           </a:p>
         </p:txBody>
@@ -1843,7 +1843,7 @@
           </a:p>
           <a:p xmlns:a="http://schemas.openxmlformats.org/drawingml/2006/main">
             <a:r>
-              <a:t>SOURCE: 4_Lab1_Exp.pdf pp. 11–14. Source decks by Prof. T. Leo Liu, Spring 2026; rewritten for Fall 2026. Native charts are calculated teaching examples, not measured laboratory data.</a:t>
+              <a:t>SOURCE: 4_Lab1_Exp.pdf pp. 11–14. Adapted from supplied prior-course source materials and rewritten for Fall 2026. Native charts are calculated teaching examples, not measured laboratory data.</a:t>
             </a:r>
           </a:p>
         </p:txBody>
@@ -1933,7 +1933,7 @@
           </a:p>
           <a:p xmlns:a="http://schemas.openxmlformats.org/drawingml/2006/main">
             <a:r>
-              <a:t>SOURCE: 4_Lab1_Exp.pdf p. 9; LAB1_MIE402.pdf p. 1. Source decks by Prof. T. Leo Liu, Spring 2026; rewritten for Fall 2026. Native charts are calculated teaching examples, not measured laboratory data.</a:t>
+              <a:t>SOURCE: 4_Lab1_Exp.pdf p. 9; LAB1_MIE402.pdf p. 1. Adapted from supplied prior-course source materials and rewritten for Fall 2026. Native charts are calculated teaching examples, not measured laboratory data.</a:t>
             </a:r>
           </a:p>
         </p:txBody>
@@ -2023,7 +2023,7 @@
           </a:p>
           <a:p xmlns:a="http://schemas.openxmlformats.org/drawingml/2006/main">
             <a:r>
-              <a:t>SOURCE: 4_Lab1_Exp.pdf p. 9; LAB1_MIE402.pdf pp. 1–2. Source decks by Prof. T. Leo Liu, Spring 2026; rewritten for Fall 2026. Native charts are calculated teaching examples, not measured laboratory data.</a:t>
+              <a:t>SOURCE: 4_Lab1_Exp.pdf p. 9; LAB1_MIE402.pdf pp. 1–2. Adapted from supplied prior-course source materials and rewritten for Fall 2026. Native charts are calculated teaching examples, not measured laboratory data.</a:t>
             </a:r>
           </a:p>
         </p:txBody>
@@ -2113,7 +2113,7 @@
           </a:p>
           <a:p xmlns:a="http://schemas.openxmlformats.org/drawingml/2006/main">
             <a:r>
-              <a:t>SOURCE: 4_Lab1_Exp.pdf pp. 9–10; LAB1_MIE402.pdf p. 2. Source decks by Prof. T. Leo Liu, Spring 2026; rewritten for Fall 2026. Native charts are calculated teaching examples, not measured laboratory data.</a:t>
+              <a:t>SOURCE: 4_Lab1_Exp.pdf pp. 9–10; LAB1_MIE402.pdf p. 2. Adapted from supplied prior-course source materials and rewritten for Fall 2026. Native charts are calculated teaching examples, not measured laboratory data.</a:t>
             </a:r>
           </a:p>
         </p:txBody>
@@ -2203,7 +2203,7 @@
           </a:p>
           <a:p xmlns:a="http://schemas.openxmlformats.org/drawingml/2006/main">
             <a:r>
-              <a:t>SOURCE: 4_Lab1_Exp.pdf pp. 9, 16–17; LAB1_MIE402.pdf p. 3. Source decks by Prof. T. Leo Liu, Spring 2026; rewritten for Fall 2026. Native charts are calculated teaching examples, not measured laboratory data.</a:t>
+              <a:t>SOURCE: 4_Lab1_Exp.pdf pp. 9, 16–17; LAB1_MIE402.pdf p. 3. Adapted from supplied prior-course source materials and rewritten for Fall 2026. Native charts are calculated teaching examples, not measured laboratory data.</a:t>
             </a:r>
           </a:p>
         </p:txBody>
@@ -2293,7 +2293,7 @@
           </a:p>
           <a:p xmlns:a="http://schemas.openxmlformats.org/drawingml/2006/main">
             <a:r>
-              <a:t>SOURCE: 4_Lab1_Exp.pdf p. 16; LAB1_PlotSignal_PlaySound.m. Source decks by Prof. T. Leo Liu, Spring 2026; rewritten for Fall 2026. Native charts are calculated teaching examples, not measured laboratory data.</a:t>
+              <a:t>SOURCE: 4_Lab1_Exp.pdf p. 16; LAB1_PlotSignal_PlaySound.m. Adapted from supplied prior-course source materials and rewritten for Fall 2026. Native charts are calculated teaching examples, not measured laboratory data.</a:t>
             </a:r>
           </a:p>
         </p:txBody>
@@ -2383,7 +2383,7 @@
           </a:p>
           <a:p xmlns:a="http://schemas.openxmlformats.org/drawingml/2006/main">
             <a:r>
-              <a:t>SOURCE: 4_Lab1_Exp.pdf p. 16; LAB1_MIE402.pdf p. 1. Source decks by Prof. T. Leo Liu, Spring 2026; rewritten for Fall 2026. Native charts are calculated teaching examples, not measured laboratory data.</a:t>
+              <a:t>SOURCE: 4_Lab1_Exp.pdf p. 16; LAB1_MIE402.pdf p. 1. Adapted from supplied prior-course source materials and rewritten for Fall 2026. Native charts are calculated teaching examples, not measured laboratory data.</a:t>
             </a:r>
           </a:p>
         </p:txBody>
@@ -2473,7 +2473,7 @@
           </a:p>
           <a:p xmlns:a="http://schemas.openxmlformats.org/drawingml/2006/main">
             <a:r>
-              <a:t>SOURCE: 2_Fundamentals.pdf p. 8; 3_Lab1_Theory.pdf p. 4. Source decks by Prof. T. Leo Liu, Spring 2026; rewritten for Fall 2026. Native charts are calculated teaching examples, not measured laboratory data.</a:t>
+              <a:t>SOURCE: 2_Fundamentals.pdf p. 8; 3_Lab1_Theory.pdf p. 4. Adapted from supplied prior-course source materials and rewritten for Fall 2026. Native charts are calculated teaching examples, not measured laboratory data.</a:t>
             </a:r>
           </a:p>
         </p:txBody>
@@ -2563,7 +2563,7 @@
           </a:p>
           <a:p xmlns:a="http://schemas.openxmlformats.org/drawingml/2006/main">
             <a:r>
-              <a:t>SOURCE: 4_Lab1_Exp.pdf pp. 17–18; LAB1_MIE402.pdf p. 1. Source decks by Prof. T. Leo Liu, Spring 2026; rewritten for Fall 2026. Native charts are calculated teaching examples, not measured laboratory data.</a:t>
+              <a:t>SOURCE: 4_Lab1_Exp.pdf pp. 17–18; LAB1_MIE402.pdf p. 1. Adapted from supplied prior-course source materials and rewritten for Fall 2026. Native charts are calculated teaching examples, not measured laboratory data.</a:t>
             </a:r>
           </a:p>
         </p:txBody>
@@ -2653,7 +2653,7 @@
           </a:p>
           <a:p xmlns:a="http://schemas.openxmlformats.org/drawingml/2006/main">
             <a:r>
-              <a:t>SOURCE: Fall 2026 Pre-Lab 1; course Colab notebook. Source decks by Prof. T. Leo Liu, Spring 2026; rewritten for Fall 2026. Native charts are calculated teaching examples, not measured laboratory data.</a:t>
+              <a:t>SOURCE: Fall 2026 Pre-Lab 1; course Colab notebook. Adapted from supplied prior-course source materials and rewritten for Fall 2026. Native charts are calculated teaching examples, not measured laboratory data.</a:t>
             </a:r>
           </a:p>
         </p:txBody>
@@ -2743,7 +2743,7 @@
           </a:p>
           <a:p xmlns:a="http://schemas.openxmlformats.org/drawingml/2006/main">
             <a:r>
-              <a:t>SOURCE: Current Fall 2026 course policy. Source decks by Prof. T. Leo Liu, Spring 2026; rewritten for Fall 2026. Native charts are calculated teaching examples, not measured laboratory data.</a:t>
+              <a:t>SOURCE: Current Fall 2026 course policy. Adapted from supplied prior-course source materials and rewritten for Fall 2026. Native charts are calculated teaching examples, not measured laboratory data.</a:t>
             </a:r>
           </a:p>
         </p:txBody>
@@ -2833,7 +2833,7 @@
           </a:p>
           <a:p xmlns:a="http://schemas.openxmlformats.org/drawingml/2006/main">
             <a:r>
-              <a:t>SOURCE: 3_Lab1_Theory.pdf p. 3; 4_Lab1_Exp.pdf p. 10. Source decks by Prof. T. Leo Liu, Spring 2026; rewritten for Fall 2026. Native charts are calculated teaching examples, not measured laboratory data.</a:t>
+              <a:t>SOURCE: 3_Lab1_Theory.pdf p. 3; 4_Lab1_Exp.pdf p. 10. Adapted from supplied prior-course source materials and rewritten for Fall 2026. Native charts are calculated teaching examples, not measured laboratory data.</a:t>
             </a:r>
           </a:p>
         </p:txBody>
@@ -2923,7 +2923,7 @@
           </a:p>
           <a:p xmlns:a="http://schemas.openxmlformats.org/drawingml/2006/main">
             <a:r>
-              <a:t>SOURCE: Earlier Lecture 02 teaching example; 4_Lab1_Exp.pdf pp. 7–8. Source decks by Prof. T. Leo Liu, Spring 2026; rewritten for Fall 2026. Native charts are calculated teaching examples, not measured laboratory data.</a:t>
+              <a:t>SOURCE: Earlier Lecture 02 teaching example; 4_Lab1_Exp.pdf pp. 7–8. Adapted from supplied prior-course source materials and rewritten for Fall 2026. Native charts are calculated teaching examples, not measured laboratory data.</a:t>
             </a:r>
           </a:p>
         </p:txBody>
@@ -3013,7 +3013,7 @@
           </a:p>
           <a:p xmlns:a="http://schemas.openxmlformats.org/drawingml/2006/main">
             <a:r>
-              <a:t>SOURCE: Earlier Lecture 02 teaching example; 4_Lab1_Exp.pdf pp. 7–8. Source decks by Prof. T. Leo Liu, Spring 2026; rewritten for Fall 2026. Native charts are calculated teaching examples, not measured laboratory data.</a:t>
+              <a:t>SOURCE: Earlier Lecture 02 teaching example; 4_Lab1_Exp.pdf pp. 7–8. Adapted from supplied prior-course source materials and rewritten for Fall 2026. Native charts are calculated teaching examples, not measured laboratory data.</a:t>
             </a:r>
           </a:p>
         </p:txBody>
@@ -3103,7 +3103,7 @@
           </a:p>
           <a:p xmlns:a="http://schemas.openxmlformats.org/drawingml/2006/main">
             <a:r>
-              <a:t>SOURCE: 3_Lab1_Theory.pdf p. 4; Fall 2026 Pre-Lab 1. Source decks by Prof. T. Leo Liu, Spring 2026; rewritten for Fall 2026. Native charts are calculated teaching examples, not measured laboratory data.</a:t>
+              <a:t>SOURCE: 3_Lab1_Theory.pdf p. 4; Fall 2026 Pre-Lab 1. Adapted from supplied prior-course source materials and rewritten for Fall 2026. Native charts are calculated teaching examples, not measured laboratory data.</a:t>
             </a:r>
           </a:p>
         </p:txBody>
@@ -3193,7 +3193,7 @@
           </a:p>
           <a:p xmlns:a="http://schemas.openxmlformats.org/drawingml/2006/main">
             <a:r>
-              <a:t>SOURCE: 3_Lab1_Theory.pdf p. 5. Source decks by Prof. T. Leo Liu, Spring 2026; rewritten for Fall 2026. Native charts are calculated teaching examples, not measured laboratory data.</a:t>
+              <a:t>SOURCE: 3_Lab1_Theory.pdf p. 5. Adapted from supplied prior-course source materials and rewritten for Fall 2026. Native charts are calculated teaching examples, not measured laboratory data.</a:t>
             </a:r>
           </a:p>
         </p:txBody>
@@ -3283,7 +3283,7 @@
           </a:p>
           <a:p xmlns:a="http://schemas.openxmlformats.org/drawingml/2006/main">
             <a:r>
-              <a:t>SOURCE: Earlier Lecture 02 teaching example; 4_Lab1_Exp.pdf pp. 7–8. Source decks by Prof. T. Leo Liu, Spring 2026; rewritten for Fall 2026. Native charts are calculated teaching examples, not measured laboratory data.</a:t>
+              <a:t>SOURCE: Earlier Lecture 02 teaching example; 4_Lab1_Exp.pdf pp. 7–8. Adapted from supplied prior-course source materials and rewritten for Fall 2026. Native charts are calculated teaching examples, not measured laboratory data.</a:t>
             </a:r>
           </a:p>
         </p:txBody>

</xml_diff>